<commit_message>
style/mise en place structure html + ajout dossier CSS
</commit_message>
<xml_diff>
--- a/docs/05_EP_wireframe.pptx
+++ b/docs/05_EP_wireframe.pptx
@@ -108,6 +108,11 @@
       </a:defRPr>
     </a:lvl9pPr>
   </p:defaultTextStyle>
+  <p:extLst>
+    <p:ext uri="{EFAFB233-063F-42B5-8137-9DF3F51BA10A}">
+      <p15:sldGuideLst xmlns:p15="http://schemas.microsoft.com/office/powerpoint/2012/main"/>
+    </p:ext>
+  </p:extLst>
 </p:presentation>
 </file>
 
@@ -242,7 +247,7 @@
           <a:p>
             <a:fld id="{4CA1B894-F06A-464E-80F2-8AA75AEEFD04}" type="datetimeFigureOut">
               <a:rPr lang="fr-FR" smtClean="0"/>
-              <a:t>06/07/2026</a:t>
+              <a:t>07/07/2026</a:t>
             </a:fld>
             <a:endParaRPr lang="fr-FR"/>
           </a:p>
@@ -412,7 +417,7 @@
           <a:p>
             <a:fld id="{4CA1B894-F06A-464E-80F2-8AA75AEEFD04}" type="datetimeFigureOut">
               <a:rPr lang="fr-FR" smtClean="0"/>
-              <a:t>06/07/2026</a:t>
+              <a:t>07/07/2026</a:t>
             </a:fld>
             <a:endParaRPr lang="fr-FR"/>
           </a:p>
@@ -592,7 +597,7 @@
           <a:p>
             <a:fld id="{4CA1B894-F06A-464E-80F2-8AA75AEEFD04}" type="datetimeFigureOut">
               <a:rPr lang="fr-FR" smtClean="0"/>
-              <a:t>06/07/2026</a:t>
+              <a:t>07/07/2026</a:t>
             </a:fld>
             <a:endParaRPr lang="fr-FR"/>
           </a:p>
@@ -762,7 +767,7 @@
           <a:p>
             <a:fld id="{4CA1B894-F06A-464E-80F2-8AA75AEEFD04}" type="datetimeFigureOut">
               <a:rPr lang="fr-FR" smtClean="0"/>
-              <a:t>06/07/2026</a:t>
+              <a:t>07/07/2026</a:t>
             </a:fld>
             <a:endParaRPr lang="fr-FR"/>
           </a:p>
@@ -1006,7 +1011,7 @@
           <a:p>
             <a:fld id="{4CA1B894-F06A-464E-80F2-8AA75AEEFD04}" type="datetimeFigureOut">
               <a:rPr lang="fr-FR" smtClean="0"/>
-              <a:t>06/07/2026</a:t>
+              <a:t>07/07/2026</a:t>
             </a:fld>
             <a:endParaRPr lang="fr-FR"/>
           </a:p>
@@ -1238,7 +1243,7 @@
           <a:p>
             <a:fld id="{4CA1B894-F06A-464E-80F2-8AA75AEEFD04}" type="datetimeFigureOut">
               <a:rPr lang="fr-FR" smtClean="0"/>
-              <a:t>06/07/2026</a:t>
+              <a:t>07/07/2026</a:t>
             </a:fld>
             <a:endParaRPr lang="fr-FR"/>
           </a:p>
@@ -1605,7 +1610,7 @@
           <a:p>
             <a:fld id="{4CA1B894-F06A-464E-80F2-8AA75AEEFD04}" type="datetimeFigureOut">
               <a:rPr lang="fr-FR" smtClean="0"/>
-              <a:t>06/07/2026</a:t>
+              <a:t>07/07/2026</a:t>
             </a:fld>
             <a:endParaRPr lang="fr-FR"/>
           </a:p>
@@ -1723,7 +1728,7 @@
           <a:p>
             <a:fld id="{4CA1B894-F06A-464E-80F2-8AA75AEEFD04}" type="datetimeFigureOut">
               <a:rPr lang="fr-FR" smtClean="0"/>
-              <a:t>06/07/2026</a:t>
+              <a:t>07/07/2026</a:t>
             </a:fld>
             <a:endParaRPr lang="fr-FR"/>
           </a:p>
@@ -1818,7 +1823,7 @@
           <a:p>
             <a:fld id="{4CA1B894-F06A-464E-80F2-8AA75AEEFD04}" type="datetimeFigureOut">
               <a:rPr lang="fr-FR" smtClean="0"/>
-              <a:t>06/07/2026</a:t>
+              <a:t>07/07/2026</a:t>
             </a:fld>
             <a:endParaRPr lang="fr-FR"/>
           </a:p>
@@ -2095,7 +2100,7 @@
           <a:p>
             <a:fld id="{4CA1B894-F06A-464E-80F2-8AA75AEEFD04}" type="datetimeFigureOut">
               <a:rPr lang="fr-FR" smtClean="0"/>
-              <a:t>06/07/2026</a:t>
+              <a:t>07/07/2026</a:t>
             </a:fld>
             <a:endParaRPr lang="fr-FR"/>
           </a:p>
@@ -2352,7 +2357,7 @@
           <a:p>
             <a:fld id="{4CA1B894-F06A-464E-80F2-8AA75AEEFD04}" type="datetimeFigureOut">
               <a:rPr lang="fr-FR" smtClean="0"/>
-              <a:t>06/07/2026</a:t>
+              <a:t>07/07/2026</a:t>
             </a:fld>
             <a:endParaRPr lang="fr-FR"/>
           </a:p>
@@ -2565,7 +2570,7 @@
           <a:p>
             <a:fld id="{4CA1B894-F06A-464E-80F2-8AA75AEEFD04}" type="datetimeFigureOut">
               <a:rPr lang="fr-FR" smtClean="0"/>
-              <a:t>06/07/2026</a:t>
+              <a:t>07/07/2026</a:t>
             </a:fld>
             <a:endParaRPr lang="fr-FR"/>
           </a:p>

</xml_diff>